<commit_message>
Migrate project to React + Vite with modular architecture and LocalStorage auth
</commit_message>
<xml_diff>
--- a/Freelancer_Marketplace_Project_Presentation.pptx
+++ b/Freelancer_Marketplace_Project_Presentation.pptx
@@ -5,20 +5,20 @@
     <p:sldMasterId id="2147483648" r:id="rId1"/>
   </p:sldMasterIdLst>
   <p:sldIdLst>
-    <p:sldId id="256" r:id="rId7"/>
-    <p:sldId id="257" r:id="rId8"/>
-    <p:sldId id="258" r:id="rId9"/>
-    <p:sldId id="259" r:id="rId10"/>
-    <p:sldId id="260" r:id="rId11"/>
-    <p:sldId id="261" r:id="rId12"/>
-    <p:sldId id="262" r:id="rId13"/>
-    <p:sldId id="263" r:id="rId14"/>
-    <p:sldId id="264" r:id="rId15"/>
-    <p:sldId id="265" r:id="rId16"/>
-    <p:sldId id="266" r:id="rId17"/>
-    <p:sldId id="267" r:id="rId18"/>
+    <p:sldId id="256" r:id="rId2"/>
+    <p:sldId id="257" r:id="rId3"/>
+    <p:sldId id="258" r:id="rId4"/>
+    <p:sldId id="259" r:id="rId5"/>
+    <p:sldId id="260" r:id="rId6"/>
+    <p:sldId id="261" r:id="rId7"/>
+    <p:sldId id="262" r:id="rId8"/>
+    <p:sldId id="263" r:id="rId9"/>
+    <p:sldId id="264" r:id="rId10"/>
+    <p:sldId id="265" r:id="rId11"/>
+    <p:sldId id="266" r:id="rId12"/>
+    <p:sldId id="267" r:id="rId13"/>
   </p:sldIdLst>
-  <p:sldSz cx="12191695" cy="6858000" type="screen4x3"/>
+  <p:sldSz cx="12192000" cy="6858000"/>
   <p:notesSz cx="6858000" cy="9144000"/>
   <p:defaultTextStyle>
     <a:defPPr>
@@ -115,7 +115,92 @@
       </a:defRPr>
     </a:lvl9pPr>
   </p:defaultTextStyle>
+  <p:extLst>
+    <p:ext uri="{EFAFB233-063F-42B5-8137-9DF3F51BA10A}">
+      <p15:sldGuideLst xmlns:p15="http://schemas.microsoft.com/office/powerpoint/2012/main">
+        <p15:guide id="1" orient="horz" pos="2160">
+          <p15:clr>
+            <a:srgbClr val="A4A3A4"/>
+          </p15:clr>
+        </p15:guide>
+        <p15:guide id="2" pos="2880">
+          <p15:clr>
+            <a:srgbClr val="A4A3A4"/>
+          </p15:clr>
+        </p15:guide>
+      </p15:sldGuideLst>
+    </p:ext>
+  </p:extLst>
 </p:presentation>
+</file>
+
+<file path=ppt/changesInfos/changesInfo1.xml><?xml version="1.0" encoding="utf-8"?>
+<pc:chgInfo xmlns:a="http://schemas.openxmlformats.org/drawingml/2006/main" xmlns:r="http://schemas.openxmlformats.org/officeDocument/2006/relationships" xmlns:ac="http://schemas.microsoft.com/office/drawing/2013/main/command" xmlns:pc="http://schemas.microsoft.com/office/powerpoint/2013/main/command">
+  <pc:docChgLst>
+    <pc:chgData name="prudhvi raj" userId="c9b5747b3a9dceeb" providerId="LiveId" clId="{EE0B5707-7B14-410F-BD35-0D6A1D0F0858}"/>
+    <pc:docChg chg="custSel modSld">
+      <pc:chgData name="prudhvi raj" userId="c9b5747b3a9dceeb" providerId="LiveId" clId="{EE0B5707-7B14-410F-BD35-0D6A1D0F0858}" dt="2026-10-05T06:18:53.062" v="40" actId="20577"/>
+      <pc:docMkLst>
+        <pc:docMk/>
+      </pc:docMkLst>
+      <pc:sldChg chg="addSp delSp modSp mod">
+        <pc:chgData name="prudhvi raj" userId="c9b5747b3a9dceeb" providerId="LiveId" clId="{EE0B5707-7B14-410F-BD35-0D6A1D0F0858}" dt="2026-10-05T06:18:53.062" v="40" actId="20577"/>
+        <pc:sldMkLst>
+          <pc:docMk/>
+          <pc:sldMk cId="0" sldId="267"/>
+        </pc:sldMkLst>
+        <pc:spChg chg="del mod">
+          <ac:chgData name="prudhvi raj" userId="c9b5747b3a9dceeb" providerId="LiveId" clId="{EE0B5707-7B14-410F-BD35-0D6A1D0F0858}" dt="2026-10-05T06:15:24.597" v="15" actId="21"/>
+          <ac:spMkLst>
+            <pc:docMk/>
+            <pc:sldMk cId="0" sldId="267"/>
+            <ac:spMk id="3" creationId="{00000000-0000-0000-0000-000000000000}"/>
+          </ac:spMkLst>
+        </pc:spChg>
+        <pc:spChg chg="del">
+          <ac:chgData name="prudhvi raj" userId="c9b5747b3a9dceeb" providerId="LiveId" clId="{EE0B5707-7B14-410F-BD35-0D6A1D0F0858}" dt="2026-10-05T06:15:29.989" v="16" actId="21"/>
+          <ac:spMkLst>
+            <pc:docMk/>
+            <pc:sldMk cId="0" sldId="267"/>
+            <ac:spMk id="4" creationId="{00000000-0000-0000-0000-000000000000}"/>
+          </ac:spMkLst>
+        </pc:spChg>
+        <pc:spChg chg="del">
+          <ac:chgData name="prudhvi raj" userId="c9b5747b3a9dceeb" providerId="LiveId" clId="{EE0B5707-7B14-410F-BD35-0D6A1D0F0858}" dt="2026-10-05T06:15:36.396" v="17" actId="21"/>
+          <ac:spMkLst>
+            <pc:docMk/>
+            <pc:sldMk cId="0" sldId="267"/>
+            <ac:spMk id="5" creationId="{00000000-0000-0000-0000-000000000000}"/>
+          </ac:spMkLst>
+        </pc:spChg>
+        <pc:spChg chg="add del mod">
+          <ac:chgData name="prudhvi raj" userId="c9b5747b3a9dceeb" providerId="LiveId" clId="{EE0B5707-7B14-410F-BD35-0D6A1D0F0858}" dt="2026-10-05T06:16:07.340" v="22"/>
+          <ac:spMkLst>
+            <pc:docMk/>
+            <pc:sldMk cId="0" sldId="267"/>
+            <ac:spMk id="6" creationId="{7B89AC30-67B0-E908-44DD-1153A2404251}"/>
+          </ac:spMkLst>
+        </pc:spChg>
+        <pc:spChg chg="add del">
+          <ac:chgData name="prudhvi raj" userId="c9b5747b3a9dceeb" providerId="LiveId" clId="{EE0B5707-7B14-410F-BD35-0D6A1D0F0858}" dt="2026-10-05T06:16:07.314" v="20" actId="21"/>
+          <ac:spMkLst>
+            <pc:docMk/>
+            <pc:sldMk cId="0" sldId="267"/>
+            <ac:spMk id="8" creationId="{189C9DB2-14D5-258E-FE18-D93593B430FE}"/>
+          </ac:spMkLst>
+        </pc:spChg>
+        <pc:spChg chg="add mod">
+          <ac:chgData name="prudhvi raj" userId="c9b5747b3a9dceeb" providerId="LiveId" clId="{EE0B5707-7B14-410F-BD35-0D6A1D0F0858}" dt="2026-10-05T06:18:53.062" v="40" actId="20577"/>
+          <ac:spMkLst>
+            <pc:docMk/>
+            <pc:sldMk cId="0" sldId="267"/>
+            <ac:spMk id="9" creationId="{F1D270C2-A104-25FD-F227-C94E40F8929C}"/>
+          </ac:spMkLst>
+        </pc:spChg>
+      </pc:sldChg>
+    </pc:docChg>
+  </pc:docChgLst>
+</pc:chgInfo>
 </file>
 
 <file path=ppt/slideLayouts/slideLayout1.xml><?xml version="1.0" encoding="utf-8"?>
@@ -156,10 +241,9 @@
           <a:lstStyle/>
           <a:p>
             <a:r>
-              <a:rPr lang="en-US" smtClean="0"/>
+              <a:rPr lang="en-US"/>
               <a:t>Click to edit Master title style</a:t>
             </a:r>
-            <a:endParaRPr lang="en-US"/>
           </a:p>
         </p:txBody>
       </p:sp>
@@ -275,10 +359,9 @@
           </a:lstStyle>
           <a:p>
             <a:r>
-              <a:rPr lang="en-US" smtClean="0"/>
+              <a:rPr lang="en-US"/>
               <a:t>Click to edit Master subtitle style</a:t>
             </a:r>
-            <a:endParaRPr lang="en-US"/>
           </a:p>
         </p:txBody>
       </p:sp>
@@ -299,7 +382,7 @@
           <a:p>
             <a:fld id="{5BCAD085-E8A6-8845-BD4E-CB4CCA059FC4}" type="datetimeFigureOut">
               <a:rPr lang="en-US" smtClean="0"/>
-              <a:t>1/27/13</a:t>
+              <a:t>10/5/2026</a:t>
             </a:fld>
             <a:endParaRPr lang="en-US"/>
           </a:p>
@@ -393,10 +476,9 @@
           <a:lstStyle/>
           <a:p>
             <a:r>
-              <a:rPr lang="en-US" smtClean="0"/>
+              <a:rPr lang="en-US"/>
               <a:t>Click to edit Master title style</a:t>
             </a:r>
-            <a:endParaRPr lang="en-US"/>
           </a:p>
         </p:txBody>
       </p:sp>
@@ -417,38 +499,37 @@
           <a:p>
             <a:pPr lvl="0"/>
             <a:r>
-              <a:rPr lang="en-US" smtClean="0"/>
+              <a:rPr lang="en-US"/>
               <a:t>Click to edit Master text styles</a:t>
             </a:r>
           </a:p>
           <a:p>
             <a:pPr lvl="1"/>
             <a:r>
-              <a:rPr lang="en-US" smtClean="0"/>
+              <a:rPr lang="en-US"/>
               <a:t>Second level</a:t>
             </a:r>
           </a:p>
           <a:p>
             <a:pPr lvl="2"/>
             <a:r>
-              <a:rPr lang="en-US" smtClean="0"/>
+              <a:rPr lang="en-US"/>
               <a:t>Third level</a:t>
             </a:r>
           </a:p>
           <a:p>
             <a:pPr lvl="3"/>
             <a:r>
-              <a:rPr lang="en-US" smtClean="0"/>
+              <a:rPr lang="en-US"/>
               <a:t>Fourth level</a:t>
             </a:r>
           </a:p>
           <a:p>
             <a:pPr lvl="4"/>
             <a:r>
-              <a:rPr lang="en-US" smtClean="0"/>
+              <a:rPr lang="en-US"/>
               <a:t>Fifth level</a:t>
             </a:r>
-            <a:endParaRPr lang="en-US"/>
           </a:p>
         </p:txBody>
       </p:sp>
@@ -469,7 +550,7 @@
           <a:p>
             <a:fld id="{5BCAD085-E8A6-8845-BD4E-CB4CCA059FC4}" type="datetimeFigureOut">
               <a:rPr lang="en-US" smtClean="0"/>
-              <a:t>1/27/13</a:t>
+              <a:t>10/5/2026</a:t>
             </a:fld>
             <a:endParaRPr lang="en-US"/>
           </a:p>
@@ -568,10 +649,9 @@
           <a:lstStyle/>
           <a:p>
             <a:r>
-              <a:rPr lang="en-US" smtClean="0"/>
+              <a:rPr lang="en-US"/>
               <a:t>Click to edit Master title style</a:t>
             </a:r>
-            <a:endParaRPr lang="en-US"/>
           </a:p>
         </p:txBody>
       </p:sp>
@@ -597,38 +677,37 @@
           <a:p>
             <a:pPr lvl="0"/>
             <a:r>
-              <a:rPr lang="en-US" smtClean="0"/>
+              <a:rPr lang="en-US"/>
               <a:t>Click to edit Master text styles</a:t>
             </a:r>
           </a:p>
           <a:p>
             <a:pPr lvl="1"/>
             <a:r>
-              <a:rPr lang="en-US" smtClean="0"/>
+              <a:rPr lang="en-US"/>
               <a:t>Second level</a:t>
             </a:r>
           </a:p>
           <a:p>
             <a:pPr lvl="2"/>
             <a:r>
-              <a:rPr lang="en-US" smtClean="0"/>
+              <a:rPr lang="en-US"/>
               <a:t>Third level</a:t>
             </a:r>
           </a:p>
           <a:p>
             <a:pPr lvl="3"/>
             <a:r>
-              <a:rPr lang="en-US" smtClean="0"/>
+              <a:rPr lang="en-US"/>
               <a:t>Fourth level</a:t>
             </a:r>
           </a:p>
           <a:p>
             <a:pPr lvl="4"/>
             <a:r>
-              <a:rPr lang="en-US" smtClean="0"/>
+              <a:rPr lang="en-US"/>
               <a:t>Fifth level</a:t>
             </a:r>
-            <a:endParaRPr lang="en-US"/>
           </a:p>
         </p:txBody>
       </p:sp>
@@ -649,7 +728,7 @@
           <a:p>
             <a:fld id="{5BCAD085-E8A6-8845-BD4E-CB4CCA059FC4}" type="datetimeFigureOut">
               <a:rPr lang="en-US" smtClean="0"/>
-              <a:t>1/27/13</a:t>
+              <a:t>10/5/2026</a:t>
             </a:fld>
             <a:endParaRPr lang="en-US"/>
           </a:p>
@@ -743,10 +822,9 @@
           <a:lstStyle/>
           <a:p>
             <a:r>
-              <a:rPr lang="en-US" smtClean="0"/>
+              <a:rPr lang="en-US"/>
               <a:t>Click to edit Master title style</a:t>
             </a:r>
-            <a:endParaRPr lang="en-US"/>
           </a:p>
         </p:txBody>
       </p:sp>
@@ -767,38 +845,37 @@
           <a:p>
             <a:pPr lvl="0"/>
             <a:r>
-              <a:rPr lang="en-US" smtClean="0"/>
+              <a:rPr lang="en-US"/>
               <a:t>Click to edit Master text styles</a:t>
             </a:r>
           </a:p>
           <a:p>
             <a:pPr lvl="1"/>
             <a:r>
-              <a:rPr lang="en-US" smtClean="0"/>
+              <a:rPr lang="en-US"/>
               <a:t>Second level</a:t>
             </a:r>
           </a:p>
           <a:p>
             <a:pPr lvl="2"/>
             <a:r>
-              <a:rPr lang="en-US" smtClean="0"/>
+              <a:rPr lang="en-US"/>
               <a:t>Third level</a:t>
             </a:r>
           </a:p>
           <a:p>
             <a:pPr lvl="3"/>
             <a:r>
-              <a:rPr lang="en-US" smtClean="0"/>
+              <a:rPr lang="en-US"/>
               <a:t>Fourth level</a:t>
             </a:r>
           </a:p>
           <a:p>
             <a:pPr lvl="4"/>
             <a:r>
-              <a:rPr lang="en-US" smtClean="0"/>
+              <a:rPr lang="en-US"/>
               <a:t>Fifth level</a:t>
             </a:r>
-            <a:endParaRPr lang="en-US"/>
           </a:p>
         </p:txBody>
       </p:sp>
@@ -819,7 +896,7 @@
           <a:p>
             <a:fld id="{5BCAD085-E8A6-8845-BD4E-CB4CCA059FC4}" type="datetimeFigureOut">
               <a:rPr lang="en-US" smtClean="0"/>
-              <a:t>1/27/13</a:t>
+              <a:t>10/5/2026</a:t>
             </a:fld>
             <a:endParaRPr lang="en-US"/>
           </a:p>
@@ -922,10 +999,9 @@
           </a:lstStyle>
           <a:p>
             <a:r>
-              <a:rPr lang="en-US" smtClean="0"/>
+              <a:rPr lang="en-US"/>
               <a:t>Click to edit Master title style</a:t>
             </a:r>
-            <a:endParaRPr lang="en-US"/>
           </a:p>
         </p:txBody>
       </p:sp>
@@ -1042,7 +1118,7 @@
           <a:p>
             <a:pPr lvl="0"/>
             <a:r>
-              <a:rPr lang="en-US" smtClean="0"/>
+              <a:rPr lang="en-US"/>
               <a:t>Click to edit Master text styles</a:t>
             </a:r>
           </a:p>
@@ -1065,7 +1141,7 @@
           <a:p>
             <a:fld id="{5BCAD085-E8A6-8845-BD4E-CB4CCA059FC4}" type="datetimeFigureOut">
               <a:rPr lang="en-US" smtClean="0"/>
-              <a:t>1/27/13</a:t>
+              <a:t>10/5/2026</a:t>
             </a:fld>
             <a:endParaRPr lang="en-US"/>
           </a:p>
@@ -1159,10 +1235,9 @@
           <a:lstStyle/>
           <a:p>
             <a:r>
-              <a:rPr lang="en-US" smtClean="0"/>
+              <a:rPr lang="en-US"/>
               <a:t>Click to edit Master title style</a:t>
             </a:r>
-            <a:endParaRPr lang="en-US"/>
           </a:p>
         </p:txBody>
       </p:sp>
@@ -1216,38 +1291,37 @@
           <a:p>
             <a:pPr lvl="0"/>
             <a:r>
-              <a:rPr lang="en-US" smtClean="0"/>
+              <a:rPr lang="en-US"/>
               <a:t>Click to edit Master text styles</a:t>
             </a:r>
           </a:p>
           <a:p>
             <a:pPr lvl="1"/>
             <a:r>
-              <a:rPr lang="en-US" smtClean="0"/>
+              <a:rPr lang="en-US"/>
               <a:t>Second level</a:t>
             </a:r>
           </a:p>
           <a:p>
             <a:pPr lvl="2"/>
             <a:r>
-              <a:rPr lang="en-US" smtClean="0"/>
+              <a:rPr lang="en-US"/>
               <a:t>Third level</a:t>
             </a:r>
           </a:p>
           <a:p>
             <a:pPr lvl="3"/>
             <a:r>
-              <a:rPr lang="en-US" smtClean="0"/>
+              <a:rPr lang="en-US"/>
               <a:t>Fourth level</a:t>
             </a:r>
           </a:p>
           <a:p>
             <a:pPr lvl="4"/>
             <a:r>
-              <a:rPr lang="en-US" smtClean="0"/>
+              <a:rPr lang="en-US"/>
               <a:t>Fifth level</a:t>
             </a:r>
-            <a:endParaRPr lang="en-US"/>
           </a:p>
         </p:txBody>
       </p:sp>
@@ -1301,38 +1375,37 @@
           <a:p>
             <a:pPr lvl="0"/>
             <a:r>
-              <a:rPr lang="en-US" smtClean="0"/>
+              <a:rPr lang="en-US"/>
               <a:t>Click to edit Master text styles</a:t>
             </a:r>
           </a:p>
           <a:p>
             <a:pPr lvl="1"/>
             <a:r>
-              <a:rPr lang="en-US" smtClean="0"/>
+              <a:rPr lang="en-US"/>
               <a:t>Second level</a:t>
             </a:r>
           </a:p>
           <a:p>
             <a:pPr lvl="2"/>
             <a:r>
-              <a:rPr lang="en-US" smtClean="0"/>
+              <a:rPr lang="en-US"/>
               <a:t>Third level</a:t>
             </a:r>
           </a:p>
           <a:p>
             <a:pPr lvl="3"/>
             <a:r>
-              <a:rPr lang="en-US" smtClean="0"/>
+              <a:rPr lang="en-US"/>
               <a:t>Fourth level</a:t>
             </a:r>
           </a:p>
           <a:p>
             <a:pPr lvl="4"/>
             <a:r>
-              <a:rPr lang="en-US" smtClean="0"/>
+              <a:rPr lang="en-US"/>
               <a:t>Fifth level</a:t>
             </a:r>
-            <a:endParaRPr lang="en-US"/>
           </a:p>
         </p:txBody>
       </p:sp>
@@ -1353,7 +1426,7 @@
           <a:p>
             <a:fld id="{5BCAD085-E8A6-8845-BD4E-CB4CCA059FC4}" type="datetimeFigureOut">
               <a:rPr lang="en-US" smtClean="0"/>
-              <a:t>1/27/13</a:t>
+              <a:t>10/5/2026</a:t>
             </a:fld>
             <a:endParaRPr lang="en-US"/>
           </a:p>
@@ -1451,10 +1524,9 @@
           </a:lstStyle>
           <a:p>
             <a:r>
-              <a:rPr lang="en-US" smtClean="0"/>
+              <a:rPr lang="en-US"/>
               <a:t>Click to edit Master title style</a:t>
             </a:r>
-            <a:endParaRPr lang="en-US"/>
           </a:p>
         </p:txBody>
       </p:sp>
@@ -1517,7 +1589,7 @@
           <a:p>
             <a:pPr lvl="0"/>
             <a:r>
-              <a:rPr lang="en-US" smtClean="0"/>
+              <a:rPr lang="en-US"/>
               <a:t>Click to edit Master text styles</a:t>
             </a:r>
           </a:p>
@@ -1573,38 +1645,37 @@
           <a:p>
             <a:pPr lvl="0"/>
             <a:r>
-              <a:rPr lang="en-US" smtClean="0"/>
+              <a:rPr lang="en-US"/>
               <a:t>Click to edit Master text styles</a:t>
             </a:r>
           </a:p>
           <a:p>
             <a:pPr lvl="1"/>
             <a:r>
-              <a:rPr lang="en-US" smtClean="0"/>
+              <a:rPr lang="en-US"/>
               <a:t>Second level</a:t>
             </a:r>
           </a:p>
           <a:p>
             <a:pPr lvl="2"/>
             <a:r>
-              <a:rPr lang="en-US" smtClean="0"/>
+              <a:rPr lang="en-US"/>
               <a:t>Third level</a:t>
             </a:r>
           </a:p>
           <a:p>
             <a:pPr lvl="3"/>
             <a:r>
-              <a:rPr lang="en-US" smtClean="0"/>
+              <a:rPr lang="en-US"/>
               <a:t>Fourth level</a:t>
             </a:r>
           </a:p>
           <a:p>
             <a:pPr lvl="4"/>
             <a:r>
-              <a:rPr lang="en-US" smtClean="0"/>
+              <a:rPr lang="en-US"/>
               <a:t>Fifth level</a:t>
             </a:r>
-            <a:endParaRPr lang="en-US"/>
           </a:p>
         </p:txBody>
       </p:sp>
@@ -1667,7 +1738,7 @@
           <a:p>
             <a:pPr lvl="0"/>
             <a:r>
-              <a:rPr lang="en-US" smtClean="0"/>
+              <a:rPr lang="en-US"/>
               <a:t>Click to edit Master text styles</a:t>
             </a:r>
           </a:p>
@@ -1723,38 +1794,37 @@
           <a:p>
             <a:pPr lvl="0"/>
             <a:r>
-              <a:rPr lang="en-US" smtClean="0"/>
+              <a:rPr lang="en-US"/>
               <a:t>Click to edit Master text styles</a:t>
             </a:r>
           </a:p>
           <a:p>
             <a:pPr lvl="1"/>
             <a:r>
-              <a:rPr lang="en-US" smtClean="0"/>
+              <a:rPr lang="en-US"/>
               <a:t>Second level</a:t>
             </a:r>
           </a:p>
           <a:p>
             <a:pPr lvl="2"/>
             <a:r>
-              <a:rPr lang="en-US" smtClean="0"/>
+              <a:rPr lang="en-US"/>
               <a:t>Third level</a:t>
             </a:r>
           </a:p>
           <a:p>
             <a:pPr lvl="3"/>
             <a:r>
-              <a:rPr lang="en-US" smtClean="0"/>
+              <a:rPr lang="en-US"/>
               <a:t>Fourth level</a:t>
             </a:r>
           </a:p>
           <a:p>
             <a:pPr lvl="4"/>
             <a:r>
-              <a:rPr lang="en-US" smtClean="0"/>
+              <a:rPr lang="en-US"/>
               <a:t>Fifth level</a:t>
             </a:r>
-            <a:endParaRPr lang="en-US"/>
           </a:p>
         </p:txBody>
       </p:sp>
@@ -1775,7 +1845,7 @@
           <a:p>
             <a:fld id="{5BCAD085-E8A6-8845-BD4E-CB4CCA059FC4}" type="datetimeFigureOut">
               <a:rPr lang="en-US" smtClean="0"/>
-              <a:t>1/27/13</a:t>
+              <a:t>10/5/2026</a:t>
             </a:fld>
             <a:endParaRPr lang="en-US"/>
           </a:p>
@@ -1869,10 +1939,9 @@
           <a:lstStyle/>
           <a:p>
             <a:r>
-              <a:rPr lang="en-US" smtClean="0"/>
+              <a:rPr lang="en-US"/>
               <a:t>Click to edit Master title style</a:t>
             </a:r>
-            <a:endParaRPr lang="en-US"/>
           </a:p>
         </p:txBody>
       </p:sp>
@@ -1893,7 +1962,7 @@
           <a:p>
             <a:fld id="{5BCAD085-E8A6-8845-BD4E-CB4CCA059FC4}" type="datetimeFigureOut">
               <a:rPr lang="en-US" smtClean="0"/>
-              <a:t>1/27/13</a:t>
+              <a:t>10/5/2026</a:t>
             </a:fld>
             <a:endParaRPr lang="en-US"/>
           </a:p>
@@ -1988,7 +2057,7 @@
           <a:p>
             <a:fld id="{5BCAD085-E8A6-8845-BD4E-CB4CCA059FC4}" type="datetimeFigureOut">
               <a:rPr lang="en-US" smtClean="0"/>
-              <a:t>1/27/13</a:t>
+              <a:t>10/5/2026</a:t>
             </a:fld>
             <a:endParaRPr lang="en-US"/>
           </a:p>
@@ -2091,10 +2160,9 @@
           </a:lstStyle>
           <a:p>
             <a:r>
-              <a:rPr lang="en-US" smtClean="0"/>
+              <a:rPr lang="en-US"/>
               <a:t>Click to edit Master title style</a:t>
             </a:r>
-            <a:endParaRPr lang="en-US"/>
           </a:p>
         </p:txBody>
       </p:sp>
@@ -2148,38 +2216,37 @@
           <a:p>
             <a:pPr lvl="0"/>
             <a:r>
-              <a:rPr lang="en-US" smtClean="0"/>
+              <a:rPr lang="en-US"/>
               <a:t>Click to edit Master text styles</a:t>
             </a:r>
           </a:p>
           <a:p>
             <a:pPr lvl="1"/>
             <a:r>
-              <a:rPr lang="en-US" smtClean="0"/>
+              <a:rPr lang="en-US"/>
               <a:t>Second level</a:t>
             </a:r>
           </a:p>
           <a:p>
             <a:pPr lvl="2"/>
             <a:r>
-              <a:rPr lang="en-US" smtClean="0"/>
+              <a:rPr lang="en-US"/>
               <a:t>Third level</a:t>
             </a:r>
           </a:p>
           <a:p>
             <a:pPr lvl="3"/>
             <a:r>
-              <a:rPr lang="en-US" smtClean="0"/>
+              <a:rPr lang="en-US"/>
               <a:t>Fourth level</a:t>
             </a:r>
           </a:p>
           <a:p>
             <a:pPr lvl="4"/>
             <a:r>
-              <a:rPr lang="en-US" smtClean="0"/>
+              <a:rPr lang="en-US"/>
               <a:t>Fifth level</a:t>
             </a:r>
-            <a:endParaRPr lang="en-US"/>
           </a:p>
         </p:txBody>
       </p:sp>
@@ -2242,7 +2309,7 @@
           <a:p>
             <a:pPr lvl="0"/>
             <a:r>
-              <a:rPr lang="en-US" smtClean="0"/>
+              <a:rPr lang="en-US"/>
               <a:t>Click to edit Master text styles</a:t>
             </a:r>
           </a:p>
@@ -2265,7 +2332,7 @@
           <a:p>
             <a:fld id="{5BCAD085-E8A6-8845-BD4E-CB4CCA059FC4}" type="datetimeFigureOut">
               <a:rPr lang="en-US" smtClean="0"/>
-              <a:t>1/27/13</a:t>
+              <a:t>10/5/2026</a:t>
             </a:fld>
             <a:endParaRPr lang="en-US"/>
           </a:p>
@@ -2368,10 +2435,9 @@
           </a:lstStyle>
           <a:p>
             <a:r>
-              <a:rPr lang="en-US" smtClean="0"/>
+              <a:rPr lang="en-US"/>
               <a:t>Click to edit Master title style</a:t>
             </a:r>
-            <a:endParaRPr lang="en-US"/>
           </a:p>
         </p:txBody>
       </p:sp>
@@ -2495,7 +2561,7 @@
           <a:p>
             <a:pPr lvl="0"/>
             <a:r>
-              <a:rPr lang="en-US" smtClean="0"/>
+              <a:rPr lang="en-US"/>
               <a:t>Click to edit Master text styles</a:t>
             </a:r>
           </a:p>
@@ -2518,7 +2584,7 @@
           <a:p>
             <a:fld id="{5BCAD085-E8A6-8845-BD4E-CB4CCA059FC4}" type="datetimeFigureOut">
               <a:rPr lang="en-US" smtClean="0"/>
-              <a:t>1/27/13</a:t>
+              <a:t>10/5/2026</a:t>
             </a:fld>
             <a:endParaRPr lang="en-US"/>
           </a:p>
@@ -2627,10 +2693,9 @@
           <a:lstStyle/>
           <a:p>
             <a:r>
-              <a:rPr lang="en-US" smtClean="0"/>
+              <a:rPr lang="en-US"/>
               <a:t>Click to edit Master title style</a:t>
             </a:r>
-            <a:endParaRPr lang="en-US"/>
           </a:p>
         </p:txBody>
       </p:sp>
@@ -2661,38 +2726,37 @@
           <a:p>
             <a:pPr lvl="0"/>
             <a:r>
-              <a:rPr lang="en-US" smtClean="0"/>
+              <a:rPr lang="en-US"/>
               <a:t>Click to edit Master text styles</a:t>
             </a:r>
           </a:p>
           <a:p>
             <a:pPr lvl="1"/>
             <a:r>
-              <a:rPr lang="en-US" smtClean="0"/>
+              <a:rPr lang="en-US"/>
               <a:t>Second level</a:t>
             </a:r>
           </a:p>
           <a:p>
             <a:pPr lvl="2"/>
             <a:r>
-              <a:rPr lang="en-US" smtClean="0"/>
+              <a:rPr lang="en-US"/>
               <a:t>Third level</a:t>
             </a:r>
           </a:p>
           <a:p>
             <a:pPr lvl="3"/>
             <a:r>
-              <a:rPr lang="en-US" smtClean="0"/>
+              <a:rPr lang="en-US"/>
               <a:t>Fourth level</a:t>
             </a:r>
           </a:p>
           <a:p>
             <a:pPr lvl="4"/>
             <a:r>
-              <a:rPr lang="en-US" smtClean="0"/>
+              <a:rPr lang="en-US"/>
               <a:t>Fifth level</a:t>
             </a:r>
-            <a:endParaRPr lang="en-US"/>
           </a:p>
         </p:txBody>
       </p:sp>
@@ -2731,7 +2795,7 @@
           <a:p>
             <a:fld id="{5BCAD085-E8A6-8845-BD4E-CB4CCA059FC4}" type="datetimeFigureOut">
               <a:rPr lang="en-US" smtClean="0"/>
-              <a:t>1/27/13</a:t>
+              <a:t>10/5/2026</a:t>
             </a:fld>
             <a:endParaRPr lang="en-US"/>
           </a:p>
@@ -3090,7 +3154,7 @@
 </file>
 
 <file path=ppt/slides/slide1.xml><?xml version="1.0" encoding="utf-8"?>
-<p:sld xmlns:a="http://schemas.openxmlformats.org/drawingml/2006/main" xmlns:p="http://schemas.openxmlformats.org/presentationml/2006/main" xmlns:r="http://schemas.openxmlformats.org/officeDocument/2006/relationships">
+<p:sld xmlns:a="http://schemas.openxmlformats.org/drawingml/2006/main" xmlns:r="http://schemas.openxmlformats.org/officeDocument/2006/relationships" xmlns:p="http://schemas.openxmlformats.org/presentationml/2006/main">
   <p:cSld>
     <p:spTree>
       <p:nvGrpSpPr>
@@ -3098,7 +3162,14 @@
         <p:cNvGrpSpPr/>
         <p:nvPr/>
       </p:nvGrpSpPr>
-      <p:grpSpPr/>
+      <p:grpSpPr>
+        <a:xfrm>
+          <a:off x="0" y="0"/>
+          <a:ext cx="0" cy="0"/>
+          <a:chOff x="0" y="0"/>
+          <a:chExt cx="0" cy="0"/>
+        </a:xfrm>
+      </p:grpSpPr>
       <p:sp>
         <p:nvSpPr>
           <p:cNvPr id="2" name="Rectangle 1"/>
@@ -3139,6 +3210,7 @@
           <a:lstStyle/>
           <a:p>
             <a:pPr algn="ctr"/>
+            <a:endParaRPr/>
           </a:p>
         </p:txBody>
       </p:sp>
@@ -3285,7 +3357,7 @@
 </file>
 
 <file path=ppt/slides/slide10.xml><?xml version="1.0" encoding="utf-8"?>
-<p:sld xmlns:a="http://schemas.openxmlformats.org/drawingml/2006/main" xmlns:p="http://schemas.openxmlformats.org/presentationml/2006/main" xmlns:r="http://schemas.openxmlformats.org/officeDocument/2006/relationships">
+<p:sld xmlns:a="http://schemas.openxmlformats.org/drawingml/2006/main" xmlns:r="http://schemas.openxmlformats.org/officeDocument/2006/relationships" xmlns:p="http://schemas.openxmlformats.org/presentationml/2006/main">
   <p:cSld>
     <p:spTree>
       <p:nvGrpSpPr>
@@ -3293,7 +3365,14 @@
         <p:cNvGrpSpPr/>
         <p:nvPr/>
       </p:nvGrpSpPr>
-      <p:grpSpPr/>
+      <p:grpSpPr>
+        <a:xfrm>
+          <a:off x="0" y="0"/>
+          <a:ext cx="0" cy="0"/>
+          <a:chOff x="0" y="0"/>
+          <a:chExt cx="0" cy="0"/>
+        </a:xfrm>
+      </p:grpSpPr>
       <p:sp>
         <p:nvSpPr>
           <p:cNvPr id="2" name="Rectangle 1"/>
@@ -3334,6 +3413,7 @@
           <a:lstStyle/>
           <a:p>
             <a:pPr algn="ctr"/>
+            <a:endParaRPr/>
           </a:p>
         </p:txBody>
       </p:sp>
@@ -3449,6 +3529,7 @@
           <a:lstStyle/>
           <a:p>
             <a:pPr algn="ctr"/>
+            <a:endParaRPr/>
           </a:p>
         </p:txBody>
       </p:sp>
@@ -3492,6 +3573,7 @@
           <a:lstStyle/>
           <a:p>
             <a:pPr algn="ctr"/>
+            <a:endParaRPr/>
           </a:p>
         </p:txBody>
       </p:sp>
@@ -3670,6 +3752,7 @@
           <a:lstStyle/>
           <a:p>
             <a:pPr algn="ctr"/>
+            <a:endParaRPr/>
           </a:p>
         </p:txBody>
       </p:sp>
@@ -3713,6 +3796,7 @@
           <a:lstStyle/>
           <a:p>
             <a:pPr algn="ctr"/>
+            <a:endParaRPr/>
           </a:p>
         </p:txBody>
       </p:sp>
@@ -3891,6 +3975,7 @@
           <a:lstStyle/>
           <a:p>
             <a:pPr algn="ctr"/>
+            <a:endParaRPr/>
           </a:p>
         </p:txBody>
       </p:sp>
@@ -3934,6 +4019,7 @@
           <a:lstStyle/>
           <a:p>
             <a:pPr algn="ctr"/>
+            <a:endParaRPr/>
           </a:p>
         </p:txBody>
       </p:sp>
@@ -4114,7 +4200,7 @@
 </file>
 
 <file path=ppt/slides/slide11.xml><?xml version="1.0" encoding="utf-8"?>
-<p:sld xmlns:a="http://schemas.openxmlformats.org/drawingml/2006/main" xmlns:p="http://schemas.openxmlformats.org/presentationml/2006/main" xmlns:r="http://schemas.openxmlformats.org/officeDocument/2006/relationships">
+<p:sld xmlns:a="http://schemas.openxmlformats.org/drawingml/2006/main" xmlns:r="http://schemas.openxmlformats.org/officeDocument/2006/relationships" xmlns:p="http://schemas.openxmlformats.org/presentationml/2006/main">
   <p:cSld>
     <p:spTree>
       <p:nvGrpSpPr>
@@ -4122,7 +4208,14 @@
         <p:cNvGrpSpPr/>
         <p:nvPr/>
       </p:nvGrpSpPr>
-      <p:grpSpPr/>
+      <p:grpSpPr>
+        <a:xfrm>
+          <a:off x="0" y="0"/>
+          <a:ext cx="0" cy="0"/>
+          <a:chOff x="0" y="0"/>
+          <a:chExt cx="0" cy="0"/>
+        </a:xfrm>
+      </p:grpSpPr>
       <p:sp>
         <p:nvSpPr>
           <p:cNvPr id="2" name="Rectangle 1"/>
@@ -4163,6 +4256,7 @@
           <a:lstStyle/>
           <a:p>
             <a:pPr algn="ctr"/>
+            <a:endParaRPr/>
           </a:p>
         </p:txBody>
       </p:sp>
@@ -4278,6 +4372,7 @@
           <a:lstStyle/>
           <a:p>
             <a:pPr algn="ctr"/>
+            <a:endParaRPr/>
           </a:p>
         </p:txBody>
       </p:sp>
@@ -4321,6 +4416,7 @@
           <a:lstStyle/>
           <a:p>
             <a:pPr algn="ctr"/>
+            <a:endParaRPr/>
           </a:p>
         </p:txBody>
       </p:sp>
@@ -4439,6 +4535,7 @@
           <a:lstStyle/>
           <a:p>
             <a:pPr algn="ctr"/>
+            <a:endParaRPr/>
           </a:p>
         </p:txBody>
       </p:sp>
@@ -4482,6 +4579,7 @@
           <a:lstStyle/>
           <a:p>
             <a:pPr algn="ctr"/>
+            <a:endParaRPr/>
           </a:p>
         </p:txBody>
       </p:sp>
@@ -4600,6 +4698,7 @@
           <a:lstStyle/>
           <a:p>
             <a:pPr algn="ctr"/>
+            <a:endParaRPr/>
           </a:p>
         </p:txBody>
       </p:sp>
@@ -4643,6 +4742,7 @@
           <a:lstStyle/>
           <a:p>
             <a:pPr algn="ctr"/>
+            <a:endParaRPr/>
           </a:p>
         </p:txBody>
       </p:sp>
@@ -4761,6 +4861,7 @@
           <a:lstStyle/>
           <a:p>
             <a:pPr algn="ctr"/>
+            <a:endParaRPr/>
           </a:p>
         </p:txBody>
       </p:sp>
@@ -4804,6 +4905,7 @@
           <a:lstStyle/>
           <a:p>
             <a:pPr algn="ctr"/>
+            <a:endParaRPr/>
           </a:p>
         </p:txBody>
       </p:sp>
@@ -4922,6 +5024,7 @@
           <a:lstStyle/>
           <a:p>
             <a:pPr algn="ctr"/>
+            <a:endParaRPr/>
           </a:p>
         </p:txBody>
       </p:sp>
@@ -4965,6 +5068,7 @@
           <a:lstStyle/>
           <a:p>
             <a:pPr algn="ctr"/>
+            <a:endParaRPr/>
           </a:p>
         </p:txBody>
       </p:sp>
@@ -5083,6 +5187,7 @@
           <a:lstStyle/>
           <a:p>
             <a:pPr algn="ctr"/>
+            <a:endParaRPr/>
           </a:p>
         </p:txBody>
       </p:sp>
@@ -5126,6 +5231,7 @@
           <a:lstStyle/>
           <a:p>
             <a:pPr algn="ctr"/>
+            <a:endParaRPr/>
           </a:p>
         </p:txBody>
       </p:sp>
@@ -5246,7 +5352,7 @@
 </file>
 
 <file path=ppt/slides/slide12.xml><?xml version="1.0" encoding="utf-8"?>
-<p:sld xmlns:a="http://schemas.openxmlformats.org/drawingml/2006/main" xmlns:p="http://schemas.openxmlformats.org/presentationml/2006/main" xmlns:r="http://schemas.openxmlformats.org/officeDocument/2006/relationships">
+<p:sld xmlns:a="http://schemas.openxmlformats.org/drawingml/2006/main" xmlns:r="http://schemas.openxmlformats.org/officeDocument/2006/relationships" xmlns:p="http://schemas.openxmlformats.org/presentationml/2006/main">
   <p:cSld>
     <p:spTree>
       <p:nvGrpSpPr>
@@ -5254,7 +5360,14 @@
         <p:cNvGrpSpPr/>
         <p:nvPr/>
       </p:nvGrpSpPr>
-      <p:grpSpPr/>
+      <p:grpSpPr>
+        <a:xfrm>
+          <a:off x="0" y="0"/>
+          <a:ext cx="0" cy="0"/>
+          <a:chOff x="0" y="0"/>
+          <a:chExt cx="0" cy="0"/>
+        </a:xfrm>
+      </p:grpSpPr>
       <p:sp>
         <p:nvSpPr>
           <p:cNvPr id="2" name="Rectangle 1"/>
@@ -5295,19 +5408,26 @@
           <a:lstStyle/>
           <a:p>
             <a:pPr algn="ctr"/>
-          </a:p>
-        </p:txBody>
-      </p:sp>
-      <p:sp>
-        <p:nvSpPr>
-          <p:cNvPr id="3" name="TextBox 2"/>
+            <a:endParaRPr/>
+          </a:p>
+        </p:txBody>
+      </p:sp>
+      <p:sp>
+        <p:nvSpPr>
+          <p:cNvPr id="9" name="TextBox 8">
+            <a:extLst>
+              <a:ext uri="{FF2B5EF4-FFF2-40B4-BE49-F238E27FC236}">
+                <a16:creationId xmlns:a16="http://schemas.microsoft.com/office/drawing/2014/main" id="{F1D270C2-A104-25FD-F227-C94E40F8929C}"/>
+              </a:ext>
+            </a:extLst>
+          </p:cNvPr>
           <p:cNvSpPr txBox="1"/>
           <p:nvPr/>
         </p:nvSpPr>
         <p:spPr>
           <a:xfrm>
-            <a:off x="914400" y="914400"/>
-            <a:ext cx="10332720" cy="731520"/>
+            <a:off x="186813" y="108154"/>
+            <a:ext cx="11700387" cy="6740307"/>
           </a:xfrm>
           <a:prstGeom prst="rect">
             <a:avLst/>
@@ -5315,154 +5435,362 @@
           <a:noFill/>
         </p:spPr>
         <p:txBody>
-          <a:bodyPr wrap="none">
+          <a:bodyPr wrap="square" rtlCol="0">
             <a:spAutoFit/>
           </a:bodyPr>
           <a:lstStyle/>
           <a:p>
-            <a:pPr>
-              <a:defRPr sz="3600" b="1">
-                <a:solidFill>
-                  <a:srgbClr val="FFFFFF"/>
-                </a:solidFill>
-              </a:defRPr>
-            </a:pPr>
-            <a:r>
-              <a:t>Project Summary</a:t>
-            </a:r>
-          </a:p>
-        </p:txBody>
-      </p:sp>
-      <p:sp>
-        <p:nvSpPr>
-          <p:cNvPr id="4" name="TextBox 3"/>
-          <p:cNvSpPr txBox="1"/>
-          <p:nvPr/>
-        </p:nvSpPr>
-        <p:spPr>
-          <a:xfrm>
-            <a:off x="1005840" y="1920240"/>
-            <a:ext cx="9784080" cy="2926080"/>
-          </a:xfrm>
-          <a:prstGeom prst="rect">
-            <a:avLst/>
-          </a:prstGeom>
-          <a:noFill/>
-        </p:spPr>
-        <p:txBody>
-          <a:bodyPr wrap="square">
-            <a:spAutoFit/>
-          </a:bodyPr>
-          <a:lstStyle/>
-          <a:p>
-            <a:pPr>
-              <a:spcAft>
-                <a:spcPts val="1000"/>
-              </a:spcAft>
-              <a:defRPr sz="1800">
-                <a:solidFill>
-                  <a:srgbClr val="E2E8F0"/>
-                </a:solidFill>
-              </a:defRPr>
-            </a:pPr>
-            <a:r>
-              <a:t>• A centralized marketplace for clients and freelancers.</a:t>
-            </a:r>
-          </a:p>
-          <a:p>
-            <a:pPr>
-              <a:spcAft>
-                <a:spcPts val="1000"/>
-              </a:spcAft>
-              <a:defRPr sz="1800">
-                <a:solidFill>
-                  <a:srgbClr val="E2E8F0"/>
-                </a:solidFill>
-              </a:defRPr>
-            </a:pPr>
-            <a:r>
-              <a:t>• A clear workflow from project posting to completion and review.</a:t>
-            </a:r>
-          </a:p>
-          <a:p>
-            <a:pPr>
-              <a:spcAft>
-                <a:spcPts val="1000"/>
-              </a:spcAft>
-              <a:defRPr sz="1800">
-                <a:solidFill>
-                  <a:srgbClr val="E2E8F0"/>
-                </a:solidFill>
-              </a:defRPr>
-            </a:pPr>
-            <a:r>
-              <a:t>• A simple frontend prototype built with HTML, CSS and JavaScript.</a:t>
-            </a:r>
-          </a:p>
-          <a:p>
-            <a:pPr>
-              <a:spcAft>
-                <a:spcPts val="1000"/>
-              </a:spcAft>
-              <a:defRPr sz="1800">
-                <a:solidFill>
-                  <a:srgbClr val="E2E8F0"/>
-                </a:solidFill>
-              </a:defRPr>
-            </a:pPr>
-            <a:r>
-              <a:t>• A scalable architecture can support backend, database, chat and payments.</a:t>
-            </a:r>
-          </a:p>
-          <a:p>
-            <a:pPr>
-              <a:spcAft>
-                <a:spcPts val="1000"/>
-              </a:spcAft>
-              <a:defRPr sz="1800">
-                <a:solidFill>
-                  <a:srgbClr val="E2E8F0"/>
-                </a:solidFill>
-              </a:defRPr>
-            </a:pPr>
-            <a:r>
-              <a:t>• The long-term goal is a trusted, efficient and easy-to-use freelance platform.</a:t>
-            </a:r>
-          </a:p>
-        </p:txBody>
-      </p:sp>
-      <p:sp>
-        <p:nvSpPr>
-          <p:cNvPr id="5" name="TextBox 4"/>
-          <p:cNvSpPr txBox="1"/>
-          <p:nvPr/>
-        </p:nvSpPr>
-        <p:spPr>
-          <a:xfrm>
-            <a:off x="1005840" y="5669280"/>
-            <a:ext cx="9875520" cy="548640"/>
-          </a:xfrm>
-          <a:prstGeom prst="rect">
-            <a:avLst/>
-          </a:prstGeom>
-          <a:noFill/>
-        </p:spPr>
-        <p:txBody>
-          <a:bodyPr wrap="none">
-            <a:spAutoFit/>
-          </a:bodyPr>
-          <a:lstStyle/>
-          <a:p>
-            <a:pPr>
-              <a:defRPr sz="2400" b="1">
-                <a:solidFill>
-                  <a:srgbClr val="93C5FD"/>
-                </a:solidFill>
-              </a:defRPr>
-            </a:pPr>
-            <a:r>
-              <a:t>Thank You</a:t>
-            </a:r>
+            <a:r>
+              <a:rPr lang="en-US" b="1" dirty="0">
+                <a:solidFill>
+                  <a:schemeClr val="bg2"/>
+                </a:solidFill>
+              </a:rPr>
+              <a:t>Conclusion:</a:t>
+            </a:r>
+          </a:p>
+          <a:p>
+            <a:r>
+              <a:rPr lang="en-US" dirty="0">
+                <a:solidFill>
+                  <a:schemeClr val="bg2"/>
+                </a:solidFill>
+              </a:rPr>
+              <a:t>Good morning ma'am.</a:t>
+            </a:r>
+          </a:p>
+          <a:p>
+            <a:r>
+              <a:rPr lang="en-US" dirty="0">
+                <a:solidFill>
+                  <a:schemeClr val="bg2"/>
+                </a:solidFill>
+              </a:rPr>
+              <a:t>To conclude, our project </a:t>
+            </a:r>
+            <a:r>
+              <a:rPr lang="en-US" b="1" dirty="0" err="1">
+                <a:solidFill>
+                  <a:schemeClr val="bg2"/>
+                </a:solidFill>
+              </a:rPr>
+              <a:t>FreelanceHub</a:t>
+            </a:r>
+            <a:r>
+              <a:rPr lang="en-US" b="1" dirty="0">
+                <a:solidFill>
+                  <a:schemeClr val="bg2"/>
+                </a:solidFill>
+              </a:rPr>
+              <a:t> – Freelancer Marketplace</a:t>
+            </a:r>
+            <a:r>
+              <a:rPr lang="en-US" dirty="0">
+                <a:solidFill>
+                  <a:schemeClr val="bg2"/>
+                </a:solidFill>
+              </a:rPr>
+              <a:t> is a frontend-based platform that connects </a:t>
+            </a:r>
+            <a:r>
+              <a:rPr lang="en-US" b="1" dirty="0">
+                <a:solidFill>
+                  <a:schemeClr val="bg2"/>
+                </a:solidFill>
+              </a:rPr>
+              <a:t>clients and freelancers</a:t>
+            </a:r>
+            <a:r>
+              <a:rPr lang="en-US" dirty="0">
+                <a:solidFill>
+                  <a:schemeClr val="bg2"/>
+                </a:solidFill>
+              </a:rPr>
+              <a:t>.</a:t>
+            </a:r>
+          </a:p>
+          <a:p>
+            <a:endParaRPr lang="en-US" dirty="0">
+              <a:solidFill>
+                <a:schemeClr val="bg2"/>
+              </a:solidFill>
+            </a:endParaRPr>
+          </a:p>
+          <a:p>
+            <a:r>
+              <a:rPr lang="en-US" dirty="0">
+                <a:solidFill>
+                  <a:schemeClr val="bg2"/>
+                </a:solidFill>
+              </a:rPr>
+              <a:t>We used </a:t>
+            </a:r>
+            <a:r>
+              <a:rPr lang="en-US" b="1" dirty="0">
+                <a:solidFill>
+                  <a:schemeClr val="bg2"/>
+                </a:solidFill>
+              </a:rPr>
+              <a:t>HTML</a:t>
+            </a:r>
+            <a:r>
+              <a:rPr lang="en-US" dirty="0">
+                <a:solidFill>
+                  <a:schemeClr val="bg2"/>
+                </a:solidFill>
+              </a:rPr>
+              <a:t> for the structure, </a:t>
+            </a:r>
+            <a:r>
+              <a:rPr lang="en-US" b="1" dirty="0">
+                <a:solidFill>
+                  <a:schemeClr val="bg2"/>
+                </a:solidFill>
+              </a:rPr>
+              <a:t>CSS</a:t>
+            </a:r>
+            <a:r>
+              <a:rPr lang="en-US" dirty="0">
+                <a:solidFill>
+                  <a:schemeClr val="bg2"/>
+                </a:solidFill>
+              </a:rPr>
+              <a:t> for the design and responsive layout, and </a:t>
+            </a:r>
+            <a:r>
+              <a:rPr lang="en-US" b="1" dirty="0">
+                <a:solidFill>
+                  <a:schemeClr val="bg2"/>
+                </a:solidFill>
+              </a:rPr>
+              <a:t>JavaScript</a:t>
+            </a:r>
+            <a:r>
+              <a:rPr lang="en-US" dirty="0">
+                <a:solidFill>
+                  <a:schemeClr val="bg2"/>
+                </a:solidFill>
+              </a:rPr>
+              <a:t> for the main functionality.</a:t>
+            </a:r>
+          </a:p>
+          <a:p>
+            <a:r>
+              <a:rPr lang="en-US" dirty="0">
+                <a:solidFill>
+                  <a:schemeClr val="bg2"/>
+                </a:solidFill>
+              </a:rPr>
+              <a:t>The project has three major parts:</a:t>
+            </a:r>
+          </a:p>
+          <a:p>
+            <a:pPr lvl="0"/>
+            <a:r>
+              <a:rPr lang="en-US" b="1" dirty="0">
+                <a:solidFill>
+                  <a:schemeClr val="bg2"/>
+                </a:solidFill>
+              </a:rPr>
+              <a:t>Marketplace Module</a:t>
+            </a:r>
+            <a:r>
+              <a:rPr lang="en-US" dirty="0">
+                <a:solidFill>
+                  <a:schemeClr val="bg2"/>
+                </a:solidFill>
+              </a:rPr>
+              <a:t> – where users can search, filter, and explore projects and freelancers.</a:t>
+            </a:r>
+          </a:p>
+          <a:p>
+            <a:pPr lvl="0"/>
+            <a:r>
+              <a:rPr lang="en-US" b="1" dirty="0">
+                <a:solidFill>
+                  <a:schemeClr val="bg2"/>
+                </a:solidFill>
+              </a:rPr>
+              <a:t>User Module</a:t>
+            </a:r>
+            <a:r>
+              <a:rPr lang="en-US" dirty="0">
+                <a:solidFill>
+                  <a:schemeClr val="bg2"/>
+                </a:solidFill>
+              </a:rPr>
+              <a:t> – where clients can post projects and freelancers can apply for projects.</a:t>
+            </a:r>
+          </a:p>
+          <a:p>
+            <a:pPr lvl="0"/>
+            <a:r>
+              <a:rPr lang="en-US" b="1" dirty="0">
+                <a:solidFill>
+                  <a:schemeClr val="bg2"/>
+                </a:solidFill>
+              </a:rPr>
+              <a:t>Admin Module</a:t>
+            </a:r>
+            <a:r>
+              <a:rPr lang="en-US" dirty="0">
+                <a:solidFill>
+                  <a:schemeClr val="bg2"/>
+                </a:solidFill>
+              </a:rPr>
+              <a:t> – where the administrator can manage users, projects, approvals, and audit logs.</a:t>
+            </a:r>
+          </a:p>
+          <a:p>
+            <a:pPr lvl="0"/>
+            <a:endParaRPr lang="en-US" dirty="0">
+              <a:solidFill>
+                <a:schemeClr val="bg2"/>
+              </a:solidFill>
+            </a:endParaRPr>
+          </a:p>
+          <a:p>
+            <a:r>
+              <a:rPr lang="en-US" dirty="0">
+                <a:solidFill>
+                  <a:schemeClr val="bg2"/>
+                </a:solidFill>
+              </a:rPr>
+              <a:t>We also implemented features such as </a:t>
+            </a:r>
+            <a:r>
+              <a:rPr lang="en-US" b="1" dirty="0">
+                <a:solidFill>
+                  <a:schemeClr val="bg2"/>
+                </a:solidFill>
+              </a:rPr>
+              <a:t>login and registration, role-based access, project posting, proposals, bookmarks, search and filters, dark/light mode, and local storage</a:t>
+            </a:r>
+            <a:r>
+              <a:rPr lang="en-US" dirty="0">
+                <a:solidFill>
+                  <a:schemeClr val="bg2"/>
+                </a:solidFill>
+              </a:rPr>
+              <a:t>.</a:t>
+            </a:r>
+          </a:p>
+          <a:p>
+            <a:endParaRPr lang="en-US" dirty="0">
+              <a:solidFill>
+                <a:schemeClr val="bg2"/>
+              </a:solidFill>
+            </a:endParaRPr>
+          </a:p>
+          <a:p>
+            <a:r>
+              <a:rPr lang="en-US" dirty="0">
+                <a:solidFill>
+                  <a:schemeClr val="bg2"/>
+                </a:solidFill>
+              </a:rPr>
+              <a:t>Through this project, we learned how frontend technologies work together to create an interactive web application and how different users can have different roles and functionalities.</a:t>
+            </a:r>
+          </a:p>
+          <a:p>
+            <a:endParaRPr lang="en-US" dirty="0">
+              <a:solidFill>
+                <a:schemeClr val="bg2"/>
+              </a:solidFill>
+            </a:endParaRPr>
+          </a:p>
+          <a:p>
+            <a:r>
+              <a:rPr lang="en-US" dirty="0">
+                <a:solidFill>
+                  <a:schemeClr val="bg2"/>
+                </a:solidFill>
+              </a:rPr>
+              <a:t>Currently, it is a </a:t>
+            </a:r>
+            <a:r>
+              <a:rPr lang="en-US" b="1" dirty="0">
+                <a:solidFill>
+                  <a:schemeClr val="bg2"/>
+                </a:solidFill>
+              </a:rPr>
+              <a:t>frontend prototype</a:t>
+            </a:r>
+            <a:r>
+              <a:rPr lang="en-US" dirty="0">
+                <a:solidFill>
+                  <a:schemeClr val="bg2"/>
+                </a:solidFill>
+              </a:rPr>
+              <a:t>, so in the future we can improve it by adding a </a:t>
+            </a:r>
+            <a:r>
+              <a:rPr lang="en-US" b="1" dirty="0">
+                <a:solidFill>
+                  <a:schemeClr val="bg2"/>
+                </a:solidFill>
+              </a:rPr>
+              <a:t>real backend, database, secure authentication, real payment and escrow systems, chat, and notifications</a:t>
+            </a:r>
+            <a:r>
+              <a:rPr lang="en-US" dirty="0">
+                <a:solidFill>
+                  <a:schemeClr val="bg2"/>
+                </a:solidFill>
+              </a:rPr>
+              <a:t>.</a:t>
+            </a:r>
+          </a:p>
+          <a:p>
+            <a:endParaRPr lang="en-US" dirty="0">
+              <a:solidFill>
+                <a:schemeClr val="bg2"/>
+              </a:solidFill>
+            </a:endParaRPr>
+          </a:p>
+          <a:p>
+            <a:r>
+              <a:rPr lang="en-US" dirty="0">
+                <a:solidFill>
+                  <a:schemeClr val="bg2"/>
+                </a:solidFill>
+              </a:rPr>
+              <a:t>Overall, this project helped us understand the complete workflow of a freelancer marketplace and gave us practical experience in </a:t>
+            </a:r>
+            <a:r>
+              <a:rPr lang="en-US" b="1" dirty="0">
+                <a:solidFill>
+                  <a:schemeClr val="bg2"/>
+                </a:solidFill>
+              </a:rPr>
+              <a:t>HTML, CSS, JavaScript, DOM manipulation, local storage, and frontend application development</a:t>
+            </a:r>
+            <a:r>
+              <a:rPr lang="en-US" dirty="0">
+                <a:solidFill>
+                  <a:schemeClr val="bg2"/>
+                </a:solidFill>
+              </a:rPr>
+              <a:t>.</a:t>
+            </a:r>
+          </a:p>
+          <a:p>
+            <a:r>
+              <a:rPr lang="en-US" b="1" dirty="0">
+                <a:solidFill>
+                  <a:schemeClr val="bg2"/>
+                </a:solidFill>
+              </a:rPr>
+              <a:t>Thank you, ma'am.</a:t>
+            </a:r>
+            <a:endParaRPr lang="en-US" dirty="0">
+              <a:solidFill>
+                <a:schemeClr val="bg2"/>
+              </a:solidFill>
+            </a:endParaRPr>
+          </a:p>
+          <a:p>
+            <a:endParaRPr lang="en-US" dirty="0"/>
           </a:p>
         </p:txBody>
       </p:sp>
@@ -5475,7 +5803,7 @@
 </file>
 
 <file path=ppt/slides/slide2.xml><?xml version="1.0" encoding="utf-8"?>
-<p:sld xmlns:a="http://schemas.openxmlformats.org/drawingml/2006/main" xmlns:p="http://schemas.openxmlformats.org/presentationml/2006/main" xmlns:r="http://schemas.openxmlformats.org/officeDocument/2006/relationships">
+<p:sld xmlns:a="http://schemas.openxmlformats.org/drawingml/2006/main" xmlns:r="http://schemas.openxmlformats.org/officeDocument/2006/relationships" xmlns:p="http://schemas.openxmlformats.org/presentationml/2006/main">
   <p:cSld>
     <p:spTree>
       <p:nvGrpSpPr>
@@ -5483,7 +5811,14 @@
         <p:cNvGrpSpPr/>
         <p:nvPr/>
       </p:nvGrpSpPr>
-      <p:grpSpPr/>
+      <p:grpSpPr>
+        <a:xfrm>
+          <a:off x="0" y="0"/>
+          <a:ext cx="0" cy="0"/>
+          <a:chOff x="0" y="0"/>
+          <a:chExt cx="0" cy="0"/>
+        </a:xfrm>
+      </p:grpSpPr>
       <p:sp>
         <p:nvSpPr>
           <p:cNvPr id="2" name="Rectangle 1"/>
@@ -5524,6 +5859,7 @@
           <a:lstStyle/>
           <a:p>
             <a:pPr algn="ctr"/>
+            <a:endParaRPr/>
           </a:p>
         </p:txBody>
       </p:sp>
@@ -5639,6 +5975,7 @@
           <a:lstStyle/>
           <a:p>
             <a:pPr algn="ctr"/>
+            <a:endParaRPr/>
           </a:p>
         </p:txBody>
       </p:sp>
@@ -5682,6 +6019,7 @@
           <a:lstStyle/>
           <a:p>
             <a:pPr algn="ctr"/>
+            <a:endParaRPr/>
           </a:p>
         </p:txBody>
       </p:sp>
@@ -5860,6 +6198,7 @@
           <a:lstStyle/>
           <a:p>
             <a:pPr algn="ctr"/>
+            <a:endParaRPr/>
           </a:p>
         </p:txBody>
       </p:sp>
@@ -5903,6 +6242,7 @@
           <a:lstStyle/>
           <a:p>
             <a:pPr algn="ctr"/>
+            <a:endParaRPr/>
           </a:p>
         </p:txBody>
       </p:sp>
@@ -6083,7 +6423,7 @@
 </file>
 
 <file path=ppt/slides/slide3.xml><?xml version="1.0" encoding="utf-8"?>
-<p:sld xmlns:a="http://schemas.openxmlformats.org/drawingml/2006/main" xmlns:p="http://schemas.openxmlformats.org/presentationml/2006/main" xmlns:r="http://schemas.openxmlformats.org/officeDocument/2006/relationships">
+<p:sld xmlns:a="http://schemas.openxmlformats.org/drawingml/2006/main" xmlns:r="http://schemas.openxmlformats.org/officeDocument/2006/relationships" xmlns:p="http://schemas.openxmlformats.org/presentationml/2006/main">
   <p:cSld>
     <p:spTree>
       <p:nvGrpSpPr>
@@ -6091,7 +6431,14 @@
         <p:cNvGrpSpPr/>
         <p:nvPr/>
       </p:nvGrpSpPr>
-      <p:grpSpPr/>
+      <p:grpSpPr>
+        <a:xfrm>
+          <a:off x="0" y="0"/>
+          <a:ext cx="0" cy="0"/>
+          <a:chOff x="0" y="0"/>
+          <a:chExt cx="0" cy="0"/>
+        </a:xfrm>
+      </p:grpSpPr>
       <p:sp>
         <p:nvSpPr>
           <p:cNvPr id="2" name="Rectangle 1"/>
@@ -6132,6 +6479,7 @@
           <a:lstStyle/>
           <a:p>
             <a:pPr algn="ctr"/>
+            <a:endParaRPr/>
           </a:p>
         </p:txBody>
       </p:sp>
@@ -6247,6 +6595,7 @@
           <a:lstStyle/>
           <a:p>
             <a:pPr algn="ctr"/>
+            <a:endParaRPr/>
           </a:p>
         </p:txBody>
       </p:sp>
@@ -6290,6 +6639,7 @@
           <a:lstStyle/>
           <a:p>
             <a:pPr algn="ctr"/>
+            <a:endParaRPr/>
           </a:p>
         </p:txBody>
       </p:sp>
@@ -6408,6 +6758,7 @@
           <a:lstStyle/>
           <a:p>
             <a:pPr algn="ctr"/>
+            <a:endParaRPr/>
           </a:p>
         </p:txBody>
       </p:sp>
@@ -6451,6 +6802,7 @@
           <a:lstStyle/>
           <a:p>
             <a:pPr algn="ctr"/>
+            <a:endParaRPr/>
           </a:p>
         </p:txBody>
       </p:sp>
@@ -6569,6 +6921,7 @@
           <a:lstStyle/>
           <a:p>
             <a:pPr algn="ctr"/>
+            <a:endParaRPr/>
           </a:p>
         </p:txBody>
       </p:sp>
@@ -6612,6 +6965,7 @@
           <a:lstStyle/>
           <a:p>
             <a:pPr algn="ctr"/>
+            <a:endParaRPr/>
           </a:p>
         </p:txBody>
       </p:sp>
@@ -6730,6 +7084,7 @@
           <a:lstStyle/>
           <a:p>
             <a:pPr algn="ctr"/>
+            <a:endParaRPr/>
           </a:p>
         </p:txBody>
       </p:sp>
@@ -6773,6 +7128,7 @@
           <a:lstStyle/>
           <a:p>
             <a:pPr algn="ctr"/>
+            <a:endParaRPr/>
           </a:p>
         </p:txBody>
       </p:sp>
@@ -6891,6 +7247,7 @@
           <a:lstStyle/>
           <a:p>
             <a:pPr algn="ctr"/>
+            <a:endParaRPr/>
           </a:p>
         </p:txBody>
       </p:sp>
@@ -6934,6 +7291,7 @@
           <a:lstStyle/>
           <a:p>
             <a:pPr algn="ctr"/>
+            <a:endParaRPr/>
           </a:p>
         </p:txBody>
       </p:sp>
@@ -7052,6 +7410,7 @@
           <a:lstStyle/>
           <a:p>
             <a:pPr algn="ctr"/>
+            <a:endParaRPr/>
           </a:p>
         </p:txBody>
       </p:sp>
@@ -7095,6 +7454,7 @@
           <a:lstStyle/>
           <a:p>
             <a:pPr algn="ctr"/>
+            <a:endParaRPr/>
           </a:p>
         </p:txBody>
       </p:sp>
@@ -7215,7 +7575,7 @@
 </file>
 
 <file path=ppt/slides/slide4.xml><?xml version="1.0" encoding="utf-8"?>
-<p:sld xmlns:a="http://schemas.openxmlformats.org/drawingml/2006/main" xmlns:p="http://schemas.openxmlformats.org/presentationml/2006/main" xmlns:r="http://schemas.openxmlformats.org/officeDocument/2006/relationships">
+<p:sld xmlns:a="http://schemas.openxmlformats.org/drawingml/2006/main" xmlns:r="http://schemas.openxmlformats.org/officeDocument/2006/relationships" xmlns:p="http://schemas.openxmlformats.org/presentationml/2006/main">
   <p:cSld>
     <p:spTree>
       <p:nvGrpSpPr>
@@ -7223,7 +7583,14 @@
         <p:cNvGrpSpPr/>
         <p:nvPr/>
       </p:nvGrpSpPr>
-      <p:grpSpPr/>
+      <p:grpSpPr>
+        <a:xfrm>
+          <a:off x="0" y="0"/>
+          <a:ext cx="0" cy="0"/>
+          <a:chOff x="0" y="0"/>
+          <a:chExt cx="0" cy="0"/>
+        </a:xfrm>
+      </p:grpSpPr>
       <p:sp>
         <p:nvSpPr>
           <p:cNvPr id="2" name="Rectangle 1"/>
@@ -7264,6 +7631,7 @@
           <a:lstStyle/>
           <a:p>
             <a:pPr algn="ctr"/>
+            <a:endParaRPr/>
           </a:p>
         </p:txBody>
       </p:sp>
@@ -7379,6 +7747,7 @@
           <a:lstStyle/>
           <a:p>
             <a:pPr algn="ctr"/>
+            <a:endParaRPr/>
           </a:p>
         </p:txBody>
       </p:sp>
@@ -7422,6 +7791,7 @@
           <a:lstStyle/>
           <a:p>
             <a:pPr algn="ctr"/>
+            <a:endParaRPr/>
           </a:p>
         </p:txBody>
       </p:sp>
@@ -7615,6 +7985,7 @@
           <a:lstStyle/>
           <a:p>
             <a:pPr algn="ctr"/>
+            <a:endParaRPr/>
           </a:p>
         </p:txBody>
       </p:sp>
@@ -7658,6 +8029,7 @@
           <a:lstStyle/>
           <a:p>
             <a:pPr algn="ctr"/>
+            <a:endParaRPr/>
           </a:p>
         </p:txBody>
       </p:sp>
@@ -7851,6 +8223,7 @@
           <a:lstStyle/>
           <a:p>
             <a:pPr algn="ctr"/>
+            <a:endParaRPr/>
           </a:p>
         </p:txBody>
       </p:sp>
@@ -7894,6 +8267,7 @@
           <a:lstStyle/>
           <a:p>
             <a:pPr algn="ctr"/>
+            <a:endParaRPr/>
           </a:p>
         </p:txBody>
       </p:sp>
@@ -8089,7 +8463,7 @@
 </file>
 
 <file path=ppt/slides/slide5.xml><?xml version="1.0" encoding="utf-8"?>
-<p:sld xmlns:a="http://schemas.openxmlformats.org/drawingml/2006/main" xmlns:p="http://schemas.openxmlformats.org/presentationml/2006/main" xmlns:r="http://schemas.openxmlformats.org/officeDocument/2006/relationships">
+<p:sld xmlns:a="http://schemas.openxmlformats.org/drawingml/2006/main" xmlns:r="http://schemas.openxmlformats.org/officeDocument/2006/relationships" xmlns:p="http://schemas.openxmlformats.org/presentationml/2006/main">
   <p:cSld>
     <p:spTree>
       <p:nvGrpSpPr>
@@ -8097,7 +8471,14 @@
         <p:cNvGrpSpPr/>
         <p:nvPr/>
       </p:nvGrpSpPr>
-      <p:grpSpPr/>
+      <p:grpSpPr>
+        <a:xfrm>
+          <a:off x="0" y="0"/>
+          <a:ext cx="0" cy="0"/>
+          <a:chOff x="0" y="0"/>
+          <a:chExt cx="0" cy="0"/>
+        </a:xfrm>
+      </p:grpSpPr>
       <p:sp>
         <p:nvSpPr>
           <p:cNvPr id="2" name="Rectangle 1"/>
@@ -8138,6 +8519,7 @@
           <a:lstStyle/>
           <a:p>
             <a:pPr algn="ctr"/>
+            <a:endParaRPr/>
           </a:p>
         </p:txBody>
       </p:sp>
@@ -8253,6 +8635,7 @@
           <a:lstStyle/>
           <a:p>
             <a:pPr algn="ctr"/>
+            <a:endParaRPr/>
           </a:p>
         </p:txBody>
       </p:sp>
@@ -8438,6 +8821,7 @@
           <a:lstStyle/>
           <a:p>
             <a:pPr algn="ctr"/>
+            <a:endParaRPr/>
           </a:p>
         </p:txBody>
       </p:sp>
@@ -8623,6 +9007,7 @@
           <a:lstStyle/>
           <a:p>
             <a:pPr algn="ctr"/>
+            <a:endParaRPr/>
           </a:p>
         </p:txBody>
       </p:sp>
@@ -8808,6 +9193,7 @@
           <a:lstStyle/>
           <a:p>
             <a:pPr algn="ctr"/>
+            <a:endParaRPr/>
           </a:p>
         </p:txBody>
       </p:sp>
@@ -8993,6 +9379,7 @@
           <a:lstStyle/>
           <a:p>
             <a:pPr algn="ctr"/>
+            <a:endParaRPr/>
           </a:p>
         </p:txBody>
       </p:sp>
@@ -9178,6 +9565,7 @@
           <a:lstStyle/>
           <a:p>
             <a:pPr algn="ctr"/>
+            <a:endParaRPr/>
           </a:p>
         </p:txBody>
       </p:sp>
@@ -9330,7 +9718,7 @@
 </file>
 
 <file path=ppt/slides/slide6.xml><?xml version="1.0" encoding="utf-8"?>
-<p:sld xmlns:a="http://schemas.openxmlformats.org/drawingml/2006/main" xmlns:p="http://schemas.openxmlformats.org/presentationml/2006/main" xmlns:r="http://schemas.openxmlformats.org/officeDocument/2006/relationships">
+<p:sld xmlns:a="http://schemas.openxmlformats.org/drawingml/2006/main" xmlns:r="http://schemas.openxmlformats.org/officeDocument/2006/relationships" xmlns:p="http://schemas.openxmlformats.org/presentationml/2006/main">
   <p:cSld>
     <p:spTree>
       <p:nvGrpSpPr>
@@ -9338,7 +9726,14 @@
         <p:cNvGrpSpPr/>
         <p:nvPr/>
       </p:nvGrpSpPr>
-      <p:grpSpPr/>
+      <p:grpSpPr>
+        <a:xfrm>
+          <a:off x="0" y="0"/>
+          <a:ext cx="0" cy="0"/>
+          <a:chOff x="0" y="0"/>
+          <a:chExt cx="0" cy="0"/>
+        </a:xfrm>
+      </p:grpSpPr>
       <p:sp>
         <p:nvSpPr>
           <p:cNvPr id="2" name="Rectangle 1"/>
@@ -9379,6 +9774,7 @@
           <a:lstStyle/>
           <a:p>
             <a:pPr algn="ctr"/>
+            <a:endParaRPr/>
           </a:p>
         </p:txBody>
       </p:sp>
@@ -9494,6 +9890,7 @@
           <a:lstStyle/>
           <a:p>
             <a:pPr algn="ctr"/>
+            <a:endParaRPr/>
           </a:p>
         </p:txBody>
       </p:sp>
@@ -9537,6 +9934,7 @@
           <a:lstStyle/>
           <a:p>
             <a:pPr algn="ctr"/>
+            <a:endParaRPr/>
           </a:p>
         </p:txBody>
       </p:sp>
@@ -9655,6 +10053,7 @@
           <a:lstStyle/>
           <a:p>
             <a:pPr algn="ctr"/>
+            <a:endParaRPr/>
           </a:p>
         </p:txBody>
       </p:sp>
@@ -9698,6 +10097,7 @@
           <a:lstStyle/>
           <a:p>
             <a:pPr algn="ctr"/>
+            <a:endParaRPr/>
           </a:p>
         </p:txBody>
       </p:sp>
@@ -9816,6 +10216,7 @@
           <a:lstStyle/>
           <a:p>
             <a:pPr algn="ctr"/>
+            <a:endParaRPr/>
           </a:p>
         </p:txBody>
       </p:sp>
@@ -9859,6 +10260,7 @@
           <a:lstStyle/>
           <a:p>
             <a:pPr algn="ctr"/>
+            <a:endParaRPr/>
           </a:p>
         </p:txBody>
       </p:sp>
@@ -9977,6 +10379,7 @@
           <a:lstStyle/>
           <a:p>
             <a:pPr algn="ctr"/>
+            <a:endParaRPr/>
           </a:p>
         </p:txBody>
       </p:sp>
@@ -10020,6 +10423,7 @@
           <a:lstStyle/>
           <a:p>
             <a:pPr algn="ctr"/>
+            <a:endParaRPr/>
           </a:p>
         </p:txBody>
       </p:sp>
@@ -10138,6 +10542,7 @@
           <a:lstStyle/>
           <a:p>
             <a:pPr algn="ctr"/>
+            <a:endParaRPr/>
           </a:p>
         </p:txBody>
       </p:sp>
@@ -10181,6 +10586,7 @@
           <a:lstStyle/>
           <a:p>
             <a:pPr algn="ctr"/>
+            <a:endParaRPr/>
           </a:p>
         </p:txBody>
       </p:sp>
@@ -10299,6 +10705,7 @@
           <a:lstStyle/>
           <a:p>
             <a:pPr algn="ctr"/>
+            <a:endParaRPr/>
           </a:p>
         </p:txBody>
       </p:sp>
@@ -10342,6 +10749,7 @@
           <a:lstStyle/>
           <a:p>
             <a:pPr algn="ctr"/>
+            <a:endParaRPr/>
           </a:p>
         </p:txBody>
       </p:sp>
@@ -10462,7 +10870,7 @@
 </file>
 
 <file path=ppt/slides/slide7.xml><?xml version="1.0" encoding="utf-8"?>
-<p:sld xmlns:a="http://schemas.openxmlformats.org/drawingml/2006/main" xmlns:p="http://schemas.openxmlformats.org/presentationml/2006/main" xmlns:r="http://schemas.openxmlformats.org/officeDocument/2006/relationships">
+<p:sld xmlns:a="http://schemas.openxmlformats.org/drawingml/2006/main" xmlns:r="http://schemas.openxmlformats.org/officeDocument/2006/relationships" xmlns:p="http://schemas.openxmlformats.org/presentationml/2006/main">
   <p:cSld>
     <p:spTree>
       <p:nvGrpSpPr>
@@ -10470,7 +10878,14 @@
         <p:cNvGrpSpPr/>
         <p:nvPr/>
       </p:nvGrpSpPr>
-      <p:grpSpPr/>
+      <p:grpSpPr>
+        <a:xfrm>
+          <a:off x="0" y="0"/>
+          <a:ext cx="0" cy="0"/>
+          <a:chOff x="0" y="0"/>
+          <a:chExt cx="0" cy="0"/>
+        </a:xfrm>
+      </p:grpSpPr>
       <p:sp>
         <p:nvSpPr>
           <p:cNvPr id="2" name="Rectangle 1"/>
@@ -10511,6 +10926,7 @@
           <a:lstStyle/>
           <a:p>
             <a:pPr algn="ctr"/>
+            <a:endParaRPr/>
           </a:p>
         </p:txBody>
       </p:sp>
@@ -10626,6 +11042,7 @@
           <a:lstStyle/>
           <a:p>
             <a:pPr algn="ctr"/>
+            <a:endParaRPr/>
           </a:p>
         </p:txBody>
       </p:sp>
@@ -10669,6 +11086,7 @@
           <a:lstStyle/>
           <a:p>
             <a:pPr algn="ctr"/>
+            <a:endParaRPr/>
           </a:p>
         </p:txBody>
       </p:sp>
@@ -10754,6 +11172,7 @@
                 </a:solidFill>
               </a:defRPr>
             </a:pPr>
+            <a:endParaRPr/>
           </a:p>
           <a:p>
             <a:pPr>
@@ -10781,6 +11200,7 @@
                 </a:solidFill>
               </a:defRPr>
             </a:pPr>
+            <a:endParaRPr/>
           </a:p>
           <a:p>
             <a:pPr>
@@ -10808,6 +11228,7 @@
                 </a:solidFill>
               </a:defRPr>
             </a:pPr>
+            <a:endParaRPr/>
           </a:p>
           <a:p>
             <a:pPr>
@@ -10868,6 +11289,7 @@
           <a:lstStyle/>
           <a:p>
             <a:pPr algn="ctr"/>
+            <a:endParaRPr/>
           </a:p>
         </p:txBody>
       </p:sp>
@@ -10911,6 +11333,7 @@
           <a:lstStyle/>
           <a:p>
             <a:pPr algn="ctr"/>
+            <a:endParaRPr/>
           </a:p>
         </p:txBody>
       </p:sp>
@@ -10996,6 +11419,7 @@
                 </a:solidFill>
               </a:defRPr>
             </a:pPr>
+            <a:endParaRPr/>
           </a:p>
           <a:p>
             <a:pPr>
@@ -11023,6 +11447,7 @@
                 </a:solidFill>
               </a:defRPr>
             </a:pPr>
+            <a:endParaRPr/>
           </a:p>
           <a:p>
             <a:pPr>
@@ -11050,6 +11475,7 @@
                 </a:solidFill>
               </a:defRPr>
             </a:pPr>
+            <a:endParaRPr/>
           </a:p>
           <a:p>
             <a:pPr>
@@ -11077,6 +11503,7 @@
                 </a:solidFill>
               </a:defRPr>
             </a:pPr>
+            <a:endParaRPr/>
           </a:p>
           <a:p>
             <a:pPr>
@@ -11137,6 +11564,7 @@
           <a:lstStyle/>
           <a:p>
             <a:pPr algn="ctr"/>
+            <a:endParaRPr/>
           </a:p>
         </p:txBody>
       </p:sp>
@@ -11180,6 +11608,7 @@
           <a:lstStyle/>
           <a:p>
             <a:pPr algn="ctr"/>
+            <a:endParaRPr/>
           </a:p>
         </p:txBody>
       </p:sp>
@@ -11265,6 +11694,7 @@
                 </a:solidFill>
               </a:defRPr>
             </a:pPr>
+            <a:endParaRPr/>
           </a:p>
           <a:p>
             <a:pPr>
@@ -11292,6 +11722,7 @@
                 </a:solidFill>
               </a:defRPr>
             </a:pPr>
+            <a:endParaRPr/>
           </a:p>
           <a:p>
             <a:pPr>
@@ -11319,6 +11750,7 @@
                 </a:solidFill>
               </a:defRPr>
             </a:pPr>
+            <a:endParaRPr/>
           </a:p>
           <a:p>
             <a:pPr>
@@ -11381,7 +11813,7 @@
 </file>
 
 <file path=ppt/slides/slide8.xml><?xml version="1.0" encoding="utf-8"?>
-<p:sld xmlns:a="http://schemas.openxmlformats.org/drawingml/2006/main" xmlns:p="http://schemas.openxmlformats.org/presentationml/2006/main" xmlns:r="http://schemas.openxmlformats.org/officeDocument/2006/relationships">
+<p:sld xmlns:a="http://schemas.openxmlformats.org/drawingml/2006/main" xmlns:r="http://schemas.openxmlformats.org/officeDocument/2006/relationships" xmlns:p="http://schemas.openxmlformats.org/presentationml/2006/main">
   <p:cSld>
     <p:spTree>
       <p:nvGrpSpPr>
@@ -11389,7 +11821,14 @@
         <p:cNvGrpSpPr/>
         <p:nvPr/>
       </p:nvGrpSpPr>
-      <p:grpSpPr/>
+      <p:grpSpPr>
+        <a:xfrm>
+          <a:off x="0" y="0"/>
+          <a:ext cx="0" cy="0"/>
+          <a:chOff x="0" y="0"/>
+          <a:chExt cx="0" cy="0"/>
+        </a:xfrm>
+      </p:grpSpPr>
       <p:sp>
         <p:nvSpPr>
           <p:cNvPr id="2" name="Rectangle 1"/>
@@ -11430,6 +11869,7 @@
           <a:lstStyle/>
           <a:p>
             <a:pPr algn="ctr"/>
+            <a:endParaRPr/>
           </a:p>
         </p:txBody>
       </p:sp>
@@ -11545,6 +11985,7 @@
           <a:lstStyle/>
           <a:p>
             <a:pPr algn="ctr"/>
+            <a:endParaRPr/>
           </a:p>
         </p:txBody>
       </p:sp>
@@ -11588,6 +12029,7 @@
           <a:lstStyle/>
           <a:p>
             <a:pPr algn="ctr"/>
+            <a:endParaRPr/>
           </a:p>
         </p:txBody>
       </p:sp>
@@ -11751,6 +12193,7 @@
           <a:lstStyle/>
           <a:p>
             <a:pPr algn="ctr"/>
+            <a:endParaRPr/>
           </a:p>
         </p:txBody>
       </p:sp>
@@ -11794,6 +12237,7 @@
           <a:lstStyle/>
           <a:p>
             <a:pPr algn="ctr"/>
+            <a:endParaRPr/>
           </a:p>
         </p:txBody>
       </p:sp>
@@ -11957,6 +12401,7 @@
           <a:lstStyle/>
           <a:p>
             <a:pPr algn="ctr"/>
+            <a:endParaRPr/>
           </a:p>
         </p:txBody>
       </p:sp>
@@ -12000,6 +12445,7 @@
           <a:lstStyle/>
           <a:p>
             <a:pPr algn="ctr"/>
+            <a:endParaRPr/>
           </a:p>
         </p:txBody>
       </p:sp>
@@ -12406,7 +12852,7 @@
 </file>
 
 <file path=ppt/slides/slide9.xml><?xml version="1.0" encoding="utf-8"?>
-<p:sld xmlns:a="http://schemas.openxmlformats.org/drawingml/2006/main" xmlns:p="http://schemas.openxmlformats.org/presentationml/2006/main" xmlns:r="http://schemas.openxmlformats.org/officeDocument/2006/relationships">
+<p:sld xmlns:a="http://schemas.openxmlformats.org/drawingml/2006/main" xmlns:r="http://schemas.openxmlformats.org/officeDocument/2006/relationships" xmlns:p="http://schemas.openxmlformats.org/presentationml/2006/main">
   <p:cSld>
     <p:spTree>
       <p:nvGrpSpPr>
@@ -12414,7 +12860,14 @@
         <p:cNvGrpSpPr/>
         <p:nvPr/>
       </p:nvGrpSpPr>
-      <p:grpSpPr/>
+      <p:grpSpPr>
+        <a:xfrm>
+          <a:off x="0" y="0"/>
+          <a:ext cx="0" cy="0"/>
+          <a:chOff x="0" y="0"/>
+          <a:chExt cx="0" cy="0"/>
+        </a:xfrm>
+      </p:grpSpPr>
       <p:sp>
         <p:nvSpPr>
           <p:cNvPr id="2" name="Rectangle 1"/>
@@ -12455,6 +12908,7 @@
           <a:lstStyle/>
           <a:p>
             <a:pPr algn="ctr"/>
+            <a:endParaRPr/>
           </a:p>
         </p:txBody>
       </p:sp>
@@ -12570,6 +13024,7 @@
           <a:lstStyle/>
           <a:p>
             <a:pPr algn="ctr"/>
+            <a:endParaRPr/>
           </a:p>
         </p:txBody>
       </p:sp>
@@ -12613,6 +13068,7 @@
           <a:lstStyle/>
           <a:p>
             <a:pPr algn="ctr"/>
+            <a:endParaRPr/>
           </a:p>
         </p:txBody>
       </p:sp>
@@ -12851,6 +13307,7 @@
           <a:lstStyle/>
           <a:p>
             <a:pPr algn="ctr"/>
+            <a:endParaRPr/>
           </a:p>
         </p:txBody>
       </p:sp>
@@ -12894,6 +13351,7 @@
           <a:lstStyle/>
           <a:p>
             <a:pPr algn="ctr"/>
+            <a:endParaRPr/>
           </a:p>
         </p:txBody>
       </p:sp>

</xml_diff>